<commit_message>
Updated Purpose and Credo
</commit_message>
<xml_diff>
--- a/docs/1_Integration/1d_Responsibility/AccelRR8 Consortium Non-Profit Organization Purpose and Credo.pptx
+++ b/docs/1_Integration/1d_Responsibility/AccelRR8 Consortium Non-Profit Organization Purpose and Credo.pptx
@@ -250,7 +250,7 @@
       <p15:sldGuideLst xmlns:p15="http://schemas.microsoft.com/office/powerpoint/2012/main"/>
     </p:ext>
     <p:ext uri="GoogleSlidesCustomDataVersion2">
-      <go:slidesCustomData xmlns:mc="http://schemas.openxmlformats.org/markup-compatibility/2006" xmlns:mv="urn:schemas-microsoft-com:mac:vml" xmlns:c="http://schemas.openxmlformats.org/drawingml/2006/chart" xmlns:dgm="http://schemas.openxmlformats.org/drawingml/2006/diagram" xmlns:o="urn:schemas-microsoft-com:office:office" xmlns:v="urn:schemas-microsoft-com:vml" xmlns:pvml="urn:schemas-microsoft-com:office:powerpoint" xmlns:com="http://schemas.openxmlformats.org/drawingml/2006/compatibility" xmlns:p14="http://schemas.microsoft.com/office/powerpoint/2010/main" xmlns:p15="http://schemas.microsoft.com/office/powerpoint/2012/main" xmlns:ahyp="http://schemas.microsoft.com/office/drawing/2018/hyperlinkcolor" xmlns:go="http://customooxmlschemas.google.com/" xmlns="" r:id="rId35" roundtripDataSignature="AMtx7mhwEp+Eio5qReXqYqUwMP31HB0A8A=="/>
+      <go:slidesCustomData xmlns="" xmlns:go="http://customooxmlschemas.google.com/" xmlns:ahyp="http://schemas.microsoft.com/office/drawing/2018/hyperlinkcolor" xmlns:p15="http://schemas.microsoft.com/office/powerpoint/2012/main" xmlns:p14="http://schemas.microsoft.com/office/powerpoint/2010/main" xmlns:com="http://schemas.openxmlformats.org/drawingml/2006/compatibility" xmlns:pvml="urn:schemas-microsoft-com:office:powerpoint" xmlns:v="urn:schemas-microsoft-com:vml" xmlns:o="urn:schemas-microsoft-com:office:office" xmlns:dgm="http://schemas.openxmlformats.org/drawingml/2006/diagram" xmlns:c="http://schemas.openxmlformats.org/drawingml/2006/chart" xmlns:mv="urn:schemas-microsoft-com:mac:vml" xmlns:mc="http://schemas.openxmlformats.org/markup-compatibility/2006" r:id="rId35" roundtripDataSignature="AMtx7mhwEp+Eio5qReXqYqUwMP31HB0A8A=="/>
     </p:ext>
   </p:extLst>
 </p:presentation>
@@ -262,6 +262,81 @@
     <p1510:client id="{69E8D294-6C36-FC4A-874A-F3BACE264DF3}" v="1" dt="2026-08-06T19:39:22.622"/>
   </p1510:revLst>
 </p1510:revInfo>
+</file>
+
+<file path=ppt/changesInfos/changesInfo1.xml><?xml version="1.0" encoding="utf-8"?>
+<pc:chgInfo xmlns:a="http://schemas.openxmlformats.org/drawingml/2006/main" xmlns:r="http://schemas.openxmlformats.org/officeDocument/2006/relationships" xmlns:ac="http://schemas.microsoft.com/office/drawing/2013/main/command" xmlns:pc="http://schemas.microsoft.com/office/powerpoint/2013/main/command">
+  <pc:docChgLst>
+    <pc:chgData name="Rich Reba" userId="55db41ab6eb3f845" providerId="LiveId" clId="{0E19DA16-244C-5B50-BE0F-52911DD4CA7E}"/>
+    <pc:docChg chg="modSld">
+      <pc:chgData name="Rich Reba" userId="55db41ab6eb3f845" providerId="LiveId" clId="{0E19DA16-244C-5B50-BE0F-52911DD4CA7E}" dt="2026-08-13T02:11:26.066" v="151" actId="20577"/>
+      <pc:docMkLst>
+        <pc:docMk/>
+      </pc:docMkLst>
+      <pc:sldChg chg="modSp mod">
+        <pc:chgData name="Rich Reba" userId="55db41ab6eb3f845" providerId="LiveId" clId="{0E19DA16-244C-5B50-BE0F-52911DD4CA7E}" dt="2026-08-13T02:11:12.969" v="149" actId="20577"/>
+        <pc:sldMkLst>
+          <pc:docMk/>
+          <pc:sldMk cId="1732335019" sldId="276"/>
+        </pc:sldMkLst>
+        <pc:spChg chg="mod">
+          <ac:chgData name="Rich Reba" userId="55db41ab6eb3f845" providerId="LiveId" clId="{0E19DA16-244C-5B50-BE0F-52911DD4CA7E}" dt="2026-08-13T02:11:12.969" v="149" actId="20577"/>
+          <ac:spMkLst>
+            <pc:docMk/>
+            <pc:sldMk cId="1732335019" sldId="276"/>
+            <ac:spMk id="96" creationId="{00000000-0000-0000-0000-000000000000}"/>
+          </ac:spMkLst>
+        </pc:spChg>
+        <pc:graphicFrameChg chg="modGraphic">
+          <ac:chgData name="Rich Reba" userId="55db41ab6eb3f845" providerId="LiveId" clId="{0E19DA16-244C-5B50-BE0F-52911DD4CA7E}" dt="2026-08-13T02:09:39.310" v="142" actId="20577"/>
+          <ac:graphicFrameMkLst>
+            <pc:docMk/>
+            <pc:sldMk cId="1732335019" sldId="276"/>
+            <ac:graphicFrameMk id="5" creationId="{4B70F3A5-8062-29A2-30D0-2783CB3DFCCA}"/>
+          </ac:graphicFrameMkLst>
+        </pc:graphicFrameChg>
+      </pc:sldChg>
+      <pc:sldChg chg="modSp mod">
+        <pc:chgData name="Rich Reba" userId="55db41ab6eb3f845" providerId="LiveId" clId="{0E19DA16-244C-5B50-BE0F-52911DD4CA7E}" dt="2026-08-13T02:11:26.066" v="151" actId="20577"/>
+        <pc:sldMkLst>
+          <pc:docMk/>
+          <pc:sldMk cId="3641467929" sldId="279"/>
+        </pc:sldMkLst>
+        <pc:spChg chg="mod">
+          <ac:chgData name="Rich Reba" userId="55db41ab6eb3f845" providerId="LiveId" clId="{0E19DA16-244C-5B50-BE0F-52911DD4CA7E}" dt="2026-08-13T02:11:26.066" v="151" actId="20577"/>
+          <ac:spMkLst>
+            <pc:docMk/>
+            <pc:sldMk cId="3641467929" sldId="279"/>
+            <ac:spMk id="9" creationId="{B00CB9DB-EFD6-82D4-90BF-BD3A581BEAD4}"/>
+          </ac:spMkLst>
+        </pc:spChg>
+      </pc:sldChg>
+      <pc:sldChg chg="modSp mod">
+        <pc:chgData name="Rich Reba" userId="55db41ab6eb3f845" providerId="LiveId" clId="{0E19DA16-244C-5B50-BE0F-52911DD4CA7E}" dt="2026-08-13T02:11:02.196" v="147" actId="20577"/>
+        <pc:sldMkLst>
+          <pc:docMk/>
+          <pc:sldMk cId="778364000" sldId="415"/>
+        </pc:sldMkLst>
+        <pc:spChg chg="mod">
+          <ac:chgData name="Rich Reba" userId="55db41ab6eb3f845" providerId="LiveId" clId="{0E19DA16-244C-5B50-BE0F-52911DD4CA7E}" dt="2026-08-13T02:10:38.460" v="145" actId="20577"/>
+          <ac:spMkLst>
+            <pc:docMk/>
+            <pc:sldMk cId="778364000" sldId="415"/>
+            <ac:spMk id="3" creationId="{7ECDCE81-629D-78C2-7157-705559E612E8}"/>
+          </ac:spMkLst>
+        </pc:spChg>
+        <pc:spChg chg="mod">
+          <ac:chgData name="Rich Reba" userId="55db41ab6eb3f845" providerId="LiveId" clId="{0E19DA16-244C-5B50-BE0F-52911DD4CA7E}" dt="2026-08-13T02:11:02.196" v="147" actId="20577"/>
+          <ac:spMkLst>
+            <pc:docMk/>
+            <pc:sldMk cId="778364000" sldId="415"/>
+            <ac:spMk id="96" creationId="{6D96EFA8-3456-DD1D-DE7A-A34ADC0618A0}"/>
+          </ac:spMkLst>
+        </pc:spChg>
+      </pc:sldChg>
+    </pc:docChg>
+  </pc:docChgLst>
+</pc:chgInfo>
 </file>
 
 <file path=ppt/notesMasters/notesMaster1.xml><?xml version="1.0" encoding="utf-8"?>
@@ -10480,13 +10555,6 @@
               <a:rPr lang="en-US" dirty="0"/>
               <a:t>Consortium Values</a:t>
             </a:r>
-            <a:br>
-              <a:rPr lang="en-US" dirty="0"/>
-            </a:br>
-            <a:r>
-              <a:rPr lang="en-US" sz="2400" i="1" dirty="0"/>
-              <a:t>Stakeholders appreciate and want to associate with our values</a:t>
-            </a:r>
             <a:endParaRPr dirty="0"/>
           </a:p>
         </p:txBody>
@@ -10506,7 +10574,7 @@
           <p:nvPr>
             <p:extLst>
               <p:ext uri="{D42A27DB-BD31-4B8C-83A1-F6EECF244321}">
-                <p14:modId xmlns:p14="http://schemas.microsoft.com/office/powerpoint/2010/main" val="3237753516"/>
+                <p14:modId xmlns:p14="http://schemas.microsoft.com/office/powerpoint/2010/main" val="3596764536"/>
               </p:ext>
             </p:extLst>
           </p:nvPr>
@@ -10584,7 +10652,7 @@
                     <a:p>
                       <a:r>
                         <a:rPr lang="en-US" dirty="0"/>
-                        <a:t>Making a meaningful contribution to our local and global community</a:t>
+                        <a:t>Making a meaningful contribution to our local and global communities</a:t>
                       </a:r>
                     </a:p>
                   </a:txBody>
@@ -10680,7 +10748,7 @@
                     <a:p>
                       <a:r>
                         <a:rPr lang="en-US" dirty="0"/>
-                        <a:t>Exceeding our collaborators’ and patrons’ expectations and making them happy</a:t>
+                        <a:t>Exceeding our subscribers’ and patrons’ expectations and making them happy</a:t>
                       </a:r>
                     </a:p>
                   </a:txBody>
@@ -10977,7 +11045,7 @@
                           <a:cs typeface="+mn-cs"/>
                           <a:sym typeface="Arial"/>
                         </a:rPr>
-                        <a:t>Holding leaders accountable for ethical, legal, and financial responsibilities </a:t>
+                        <a:t>Demonstrating ethical, legal, financial, social, and environmental responsibility</a:t>
                       </a:r>
                     </a:p>
                   </a:txBody>
@@ -11118,13 +11186,6 @@
               <a:rPr lang="en-US" dirty="0"/>
               <a:t>Working with AccelRR8 LLC</a:t>
             </a:r>
-            <a:br>
-              <a:rPr lang="en-US" dirty="0"/>
-            </a:br>
-            <a:r>
-              <a:rPr lang="en-US" sz="2400" i="1" dirty="0"/>
-              <a:t>Stakeholders appreciate and want to associate with our values</a:t>
-            </a:r>
             <a:endParaRPr dirty="0"/>
           </a:p>
         </p:txBody>
@@ -11174,7 +11235,7 @@
                 <a:latin typeface="Arial" panose="020B0604020202020204" pitchFamily="34" charset="0"/>
                 <a:cs typeface="Arial" panose="020B0604020202020204" pitchFamily="34" charset="0"/>
               </a:rPr>
-              <a:t>means we must be transparent about our ethical relationship with AccelRR8 LLC</a:t>
+              <a:t>means we are transparent about our ethical relationship with AccelRR8 LLC</a:t>
             </a:r>
           </a:p>
           <a:p>
@@ -11611,13 +11672,6 @@
             <a:r>
               <a:rPr lang="en-US" dirty="0"/>
               <a:t>Consortium Culture</a:t>
-            </a:r>
-            <a:br>
-              <a:rPr lang="en-US" dirty="0"/>
-            </a:br>
-            <a:r>
-              <a:rPr lang="en-US" sz="2400" i="1" dirty="0"/>
-              <a:t>Stakeholders appreciate and want to associate with our culture</a:t>
             </a:r>
             <a:endParaRPr dirty="0"/>
           </a:p>

</xml_diff>